<commit_message>
Remove Confidential watermark from template
Two shapes baked into the slide master ("Classification: Confidential"
top-center, and a diagonal "Confidential" stamp) were rendering on every
slide. Removed both from slideMaster1.xml — they applied to all layouts
since nothing overrode them per-layout.

Co-Authored-By: Claude Sonnet 5 <noreply@anthropic.com>
</commit_message>
<xml_diff>
--- a/assets/SALIC_template.pptx
+++ b/assets/SALIC_template.pptx
@@ -17917,106 +17917,6 @@
           </a:p>
         </p:txBody>
       </p:sp>
-      <p:sp>
-        <p:nvSpPr>
-          <p:cNvPr id="19" name="Google Shape;19;p1"/>
-          <p:cNvSpPr txBox="1"/>
-          <p:nvPr/>
-        </p:nvSpPr>
-        <p:spPr>
-          <a:xfrm>
-            <a:off x="11444288" y="63500"/>
-            <a:ext cx="1546288" cy="152400"/>
-          </a:xfrm>
-          <a:prstGeom prst="rect">
-            <a:avLst/>
-          </a:prstGeom>
-          <a:noFill/>
-          <a:ln>
-            <a:noFill/>
-          </a:ln>
-        </p:spPr>
-        <p:txBody>
-          <a:bodyPr anchorCtr="0" anchor="t" bIns="0" lIns="0" spcFirstLastPara="1" rIns="0" wrap="square" tIns="0">
-            <a:spAutoFit/>
-          </a:bodyPr>
-          <a:lstStyle/>
-          <a:p>
-            <a:pPr indent="0" lvl="0" marL="0" marR="0" rtl="1" algn="l">
-              <a:spcBef>
-                <a:spcPts val="0"/>
-              </a:spcBef>
-              <a:spcAft>
-                <a:spcPts val="0"/>
-              </a:spcAft>
-              <a:buNone/>
-            </a:pPr>
-            <a:r>
-              <a:rPr b="0" i="0" lang="en-US" sz="1000" u="none" cap="none" strike="noStrike">
-                <a:solidFill>
-                  <a:srgbClr val="FF0000"/>
-                </a:solidFill>
-                <a:latin typeface="Arial"/>
-                <a:ea typeface="Arial"/>
-                <a:cs typeface="Arial"/>
-                <a:sym typeface="Arial"/>
-              </a:rPr>
-              <a:t>Classification: Confidential </a:t>
-            </a:r>
-            <a:endParaRPr/>
-          </a:p>
-        </p:txBody>
-      </p:sp>
-      <p:sp>
-        <p:nvSpPr>
-          <p:cNvPr id="20" name="Google Shape;20;p1"/>
-          <p:cNvSpPr txBox="1"/>
-          <p:nvPr/>
-        </p:nvSpPr>
-        <p:spPr>
-          <a:xfrm rot="-1800000">
-            <a:off x="10498138" y="6477000"/>
-            <a:ext cx="3644963" cy="762000"/>
-          </a:xfrm>
-          <a:prstGeom prst="rect">
-            <a:avLst/>
-          </a:prstGeom>
-          <a:noFill/>
-          <a:ln>
-            <a:noFill/>
-          </a:ln>
-        </p:spPr>
-        <p:txBody>
-          <a:bodyPr anchorCtr="0" anchor="t" bIns="0" lIns="0" spcFirstLastPara="1" rIns="0" wrap="square" tIns="0">
-            <a:spAutoFit/>
-          </a:bodyPr>
-          <a:lstStyle/>
-          <a:p>
-            <a:pPr indent="0" lvl="0" marL="0" marR="0" rtl="1" algn="l">
-              <a:spcBef>
-                <a:spcPts val="0"/>
-              </a:spcBef>
-              <a:spcAft>
-                <a:spcPts val="0"/>
-              </a:spcAft>
-              <a:buNone/>
-            </a:pPr>
-            <a:r>
-              <a:rPr b="0" i="0" lang="en-US" sz="5000" u="none" cap="none" strike="noStrike">
-                <a:solidFill>
-                  <a:srgbClr val="FF0000"/>
-                </a:solidFill>
-                <a:latin typeface="Arial"/>
-                <a:ea typeface="Arial"/>
-                <a:cs typeface="Arial"/>
-                <a:sym typeface="Arial"/>
-              </a:rPr>
-              <a:t>Confidential </a:t>
-            </a:r>
-            <a:endParaRPr/>
-          </a:p>
-        </p:txBody>
-      </p:sp>
     </p:spTree>
   </p:cSld>
   <p:clrMap accent1="accent1" accent2="accent2" accent3="accent3" accent4="accent4" accent5="accent5" accent6="accent6" bg1="lt1" bg2="dk2" tx1="dk1" tx2="lt2" folHlink="folHlink" hlink="hlink"/>

</xml_diff>